<commit_message>
add figure for hybrid intelligence
</commit_message>
<xml_diff>
--- a/ai.pptx
+++ b/ai.pptx
@@ -7,6 +7,7 @@
   <p:sldIdLst>
     <p:sldId id="256" r:id="rId2"/>
     <p:sldId id="257" r:id="rId3"/>
+    <p:sldId id="258" r:id="rId4"/>
   </p:sldIdLst>
   <p:sldSz cx="12192000" cy="6858000"/>
   <p:notesSz cx="6858000" cy="9144000"/>
@@ -262,7 +263,7 @@
           <a:p>
             <a:fld id="{B33CEA90-FFDE-4231-A305-5118E04EEDC1}" type="datetimeFigureOut">
               <a:rPr lang="en-US" smtClean="0"/>
-              <a:t>4/14/2026</a:t>
+              <a:t>5/12/2026</a:t>
             </a:fld>
             <a:endParaRPr lang="en-US"/>
           </a:p>
@@ -462,7 +463,7 @@
           <a:p>
             <a:fld id="{B33CEA90-FFDE-4231-A305-5118E04EEDC1}" type="datetimeFigureOut">
               <a:rPr lang="en-US" smtClean="0"/>
-              <a:t>4/14/2026</a:t>
+              <a:t>5/12/2026</a:t>
             </a:fld>
             <a:endParaRPr lang="en-US"/>
           </a:p>
@@ -672,7 +673,7 @@
           <a:p>
             <a:fld id="{B33CEA90-FFDE-4231-A305-5118E04EEDC1}" type="datetimeFigureOut">
               <a:rPr lang="en-US" smtClean="0"/>
-              <a:t>4/14/2026</a:t>
+              <a:t>5/12/2026</a:t>
             </a:fld>
             <a:endParaRPr lang="en-US"/>
           </a:p>
@@ -872,7 +873,7 @@
           <a:p>
             <a:fld id="{B33CEA90-FFDE-4231-A305-5118E04EEDC1}" type="datetimeFigureOut">
               <a:rPr lang="en-US" smtClean="0"/>
-              <a:t>4/14/2026</a:t>
+              <a:t>5/12/2026</a:t>
             </a:fld>
             <a:endParaRPr lang="en-US"/>
           </a:p>
@@ -1148,7 +1149,7 @@
           <a:p>
             <a:fld id="{B33CEA90-FFDE-4231-A305-5118E04EEDC1}" type="datetimeFigureOut">
               <a:rPr lang="en-US" smtClean="0"/>
-              <a:t>4/14/2026</a:t>
+              <a:t>5/12/2026</a:t>
             </a:fld>
             <a:endParaRPr lang="en-US"/>
           </a:p>
@@ -1416,7 +1417,7 @@
           <a:p>
             <a:fld id="{B33CEA90-FFDE-4231-A305-5118E04EEDC1}" type="datetimeFigureOut">
               <a:rPr lang="en-US" smtClean="0"/>
-              <a:t>4/14/2026</a:t>
+              <a:t>5/12/2026</a:t>
             </a:fld>
             <a:endParaRPr lang="en-US"/>
           </a:p>
@@ -1831,7 +1832,7 @@
           <a:p>
             <a:fld id="{B33CEA90-FFDE-4231-A305-5118E04EEDC1}" type="datetimeFigureOut">
               <a:rPr lang="en-US" smtClean="0"/>
-              <a:t>4/14/2026</a:t>
+              <a:t>5/12/2026</a:t>
             </a:fld>
             <a:endParaRPr lang="en-US"/>
           </a:p>
@@ -1973,7 +1974,7 @@
           <a:p>
             <a:fld id="{B33CEA90-FFDE-4231-A305-5118E04EEDC1}" type="datetimeFigureOut">
               <a:rPr lang="en-US" smtClean="0"/>
-              <a:t>4/14/2026</a:t>
+              <a:t>5/12/2026</a:t>
             </a:fld>
             <a:endParaRPr lang="en-US"/>
           </a:p>
@@ -2086,7 +2087,7 @@
           <a:p>
             <a:fld id="{B33CEA90-FFDE-4231-A305-5118E04EEDC1}" type="datetimeFigureOut">
               <a:rPr lang="en-US" smtClean="0"/>
-              <a:t>4/14/2026</a:t>
+              <a:t>5/12/2026</a:t>
             </a:fld>
             <a:endParaRPr lang="en-US"/>
           </a:p>
@@ -2399,7 +2400,7 @@
           <a:p>
             <a:fld id="{B33CEA90-FFDE-4231-A305-5118E04EEDC1}" type="datetimeFigureOut">
               <a:rPr lang="en-US" smtClean="0"/>
-              <a:t>4/14/2026</a:t>
+              <a:t>5/12/2026</a:t>
             </a:fld>
             <a:endParaRPr lang="en-US"/>
           </a:p>
@@ -2688,7 +2689,7 @@
           <a:p>
             <a:fld id="{B33CEA90-FFDE-4231-A305-5118E04EEDC1}" type="datetimeFigureOut">
               <a:rPr lang="en-US" smtClean="0"/>
-              <a:t>4/14/2026</a:t>
+              <a:t>5/12/2026</a:t>
             </a:fld>
             <a:endParaRPr lang="en-US"/>
           </a:p>
@@ -2931,7 +2932,7 @@
           <a:p>
             <a:fld id="{B33CEA90-FFDE-4231-A305-5118E04EEDC1}" type="datetimeFigureOut">
               <a:rPr lang="en-US" smtClean="0"/>
-              <a:t>4/14/2026</a:t>
+              <a:t>5/12/2026</a:t>
             </a:fld>
             <a:endParaRPr lang="en-US"/>
           </a:p>
@@ -4232,6 +4233,296 @@
 </p:sld>
 </file>
 
+<file path=ppt/slides/slide3.xml><?xml version="1.0" encoding="utf-8"?>
+<p:sld xmlns:a="http://schemas.openxmlformats.org/drawingml/2006/main" xmlns:r="http://schemas.openxmlformats.org/officeDocument/2006/relationships" xmlns:p="http://schemas.openxmlformats.org/presentationml/2006/main">
+  <p:cSld>
+    <p:spTree>
+      <p:nvGrpSpPr>
+        <p:cNvPr id="1" name=""/>
+        <p:cNvGrpSpPr/>
+        <p:nvPr/>
+      </p:nvGrpSpPr>
+      <p:grpSpPr>
+        <a:xfrm>
+          <a:off x="0" y="0"/>
+          <a:ext cx="0" cy="0"/>
+          <a:chOff x="0" y="0"/>
+          <a:chExt cx="0" cy="0"/>
+        </a:xfrm>
+      </p:grpSpPr>
+      <p:sp>
+        <p:nvSpPr>
+          <p:cNvPr id="4" name="Ovaal 3">
+            <a:extLst>
+              <a:ext uri="{FF2B5EF4-FFF2-40B4-BE49-F238E27FC236}">
+                <a16:creationId xmlns:a16="http://schemas.microsoft.com/office/drawing/2014/main" id="{3CCB7996-2436-C851-581F-952ECA76ACD9}"/>
+              </a:ext>
+            </a:extLst>
+          </p:cNvPr>
+          <p:cNvSpPr/>
+          <p:nvPr/>
+        </p:nvSpPr>
+        <p:spPr>
+          <a:xfrm>
+            <a:off x="4342295" y="1322553"/>
+            <a:ext cx="5076755" cy="4212893"/>
+          </a:xfrm>
+          <a:prstGeom prst="ellipse">
+            <a:avLst/>
+          </a:prstGeom>
+          <a:noFill/>
+        </p:spPr>
+        <p:style>
+          <a:lnRef idx="2">
+            <a:schemeClr val="accent1">
+              <a:shade val="15000"/>
+            </a:schemeClr>
+          </a:lnRef>
+          <a:fillRef idx="1">
+            <a:schemeClr val="accent1"/>
+          </a:fillRef>
+          <a:effectRef idx="0">
+            <a:schemeClr val="accent1"/>
+          </a:effectRef>
+          <a:fontRef idx="minor">
+            <a:schemeClr val="lt1"/>
+          </a:fontRef>
+        </p:style>
+        <p:txBody>
+          <a:bodyPr rtlCol="0" anchor="ctr"/>
+          <a:lstStyle/>
+          <a:p>
+            <a:pPr algn="ctr"/>
+            <a:endParaRPr lang="en-US" dirty="0"/>
+          </a:p>
+        </p:txBody>
+      </p:sp>
+      <p:sp>
+        <p:nvSpPr>
+          <p:cNvPr id="5" name="Ovaal 4">
+            <a:extLst>
+              <a:ext uri="{FF2B5EF4-FFF2-40B4-BE49-F238E27FC236}">
+                <a16:creationId xmlns:a16="http://schemas.microsoft.com/office/drawing/2014/main" id="{FAC0EF69-7045-F40A-AB16-2F2C48DB0311}"/>
+              </a:ext>
+            </a:extLst>
+          </p:cNvPr>
+          <p:cNvSpPr/>
+          <p:nvPr/>
+        </p:nvSpPr>
+        <p:spPr>
+          <a:xfrm>
+            <a:off x="1294295" y="1322553"/>
+            <a:ext cx="5076755" cy="4212893"/>
+          </a:xfrm>
+          <a:prstGeom prst="ellipse">
+            <a:avLst/>
+          </a:prstGeom>
+          <a:noFill/>
+        </p:spPr>
+        <p:style>
+          <a:lnRef idx="2">
+            <a:schemeClr val="accent1">
+              <a:shade val="15000"/>
+            </a:schemeClr>
+          </a:lnRef>
+          <a:fillRef idx="1">
+            <a:schemeClr val="accent1"/>
+          </a:fillRef>
+          <a:effectRef idx="0">
+            <a:schemeClr val="accent1"/>
+          </a:effectRef>
+          <a:fontRef idx="minor">
+            <a:schemeClr val="lt1"/>
+          </a:fontRef>
+        </p:style>
+        <p:txBody>
+          <a:bodyPr rtlCol="0" anchor="ctr"/>
+          <a:lstStyle/>
+          <a:p>
+            <a:pPr algn="ctr"/>
+            <a:endParaRPr lang="en-US" dirty="0"/>
+          </a:p>
+        </p:txBody>
+      </p:sp>
+      <p:sp>
+        <p:nvSpPr>
+          <p:cNvPr id="6" name="Tekstvak 5">
+            <a:extLst>
+              <a:ext uri="{FF2B5EF4-FFF2-40B4-BE49-F238E27FC236}">
+                <a16:creationId xmlns:a16="http://schemas.microsoft.com/office/drawing/2014/main" id="{E9A5E818-3EF6-8F96-2EE3-D058E905944A}"/>
+              </a:ext>
+            </a:extLst>
+          </p:cNvPr>
+          <p:cNvSpPr txBox="1"/>
+          <p:nvPr/>
+        </p:nvSpPr>
+        <p:spPr>
+          <a:xfrm>
+            <a:off x="2601952" y="1512683"/>
+            <a:ext cx="2169414" cy="369332"/>
+          </a:xfrm>
+          <a:prstGeom prst="rect">
+            <a:avLst/>
+          </a:prstGeom>
+          <a:noFill/>
+          <a:ln>
+            <a:noFill/>
+          </a:ln>
+        </p:spPr>
+        <p:style>
+          <a:lnRef idx="0">
+            <a:scrgbClr r="0" g="0" b="0"/>
+          </a:lnRef>
+          <a:fillRef idx="0">
+            <a:scrgbClr r="0" g="0" b="0"/>
+          </a:fillRef>
+          <a:effectRef idx="0">
+            <a:scrgbClr r="0" g="0" b="0"/>
+          </a:effectRef>
+          <a:fontRef idx="minor">
+            <a:schemeClr val="dk1"/>
+          </a:fontRef>
+        </p:style>
+        <p:txBody>
+          <a:bodyPr wrap="square" rtlCol="0">
+            <a:spAutoFit/>
+          </a:bodyPr>
+          <a:lstStyle/>
+          <a:p>
+            <a:pPr algn="ctr"/>
+            <a:r>
+              <a:rPr lang="en-US" dirty="0"/>
+              <a:t>Artificial Intelligence</a:t>
+            </a:r>
+          </a:p>
+        </p:txBody>
+      </p:sp>
+      <p:sp>
+        <p:nvSpPr>
+          <p:cNvPr id="7" name="Tekstvak 6">
+            <a:extLst>
+              <a:ext uri="{FF2B5EF4-FFF2-40B4-BE49-F238E27FC236}">
+                <a16:creationId xmlns:a16="http://schemas.microsoft.com/office/drawing/2014/main" id="{6A43DAC7-7EE9-7B81-98AA-61B16DB3F767}"/>
+              </a:ext>
+            </a:extLst>
+          </p:cNvPr>
+          <p:cNvSpPr txBox="1"/>
+          <p:nvPr/>
+        </p:nvSpPr>
+        <p:spPr>
+          <a:xfrm>
+            <a:off x="5941979" y="1512683"/>
+            <a:ext cx="2169414" cy="369332"/>
+          </a:xfrm>
+          <a:prstGeom prst="rect">
+            <a:avLst/>
+          </a:prstGeom>
+          <a:noFill/>
+          <a:ln>
+            <a:noFill/>
+          </a:ln>
+        </p:spPr>
+        <p:style>
+          <a:lnRef idx="0">
+            <a:scrgbClr r="0" g="0" b="0"/>
+          </a:lnRef>
+          <a:fillRef idx="0">
+            <a:scrgbClr r="0" g="0" b="0"/>
+          </a:fillRef>
+          <a:effectRef idx="0">
+            <a:scrgbClr r="0" g="0" b="0"/>
+          </a:effectRef>
+          <a:fontRef idx="minor">
+            <a:schemeClr val="dk1"/>
+          </a:fontRef>
+        </p:style>
+        <p:txBody>
+          <a:bodyPr wrap="square" rtlCol="0">
+            <a:spAutoFit/>
+          </a:bodyPr>
+          <a:lstStyle/>
+          <a:p>
+            <a:pPr algn="ctr"/>
+            <a:r>
+              <a:rPr lang="en-US" dirty="0"/>
+              <a:t>Human Intelligence</a:t>
+            </a:r>
+          </a:p>
+        </p:txBody>
+      </p:sp>
+      <p:sp>
+        <p:nvSpPr>
+          <p:cNvPr id="8" name="Tekstvak 7">
+            <a:extLst>
+              <a:ext uri="{FF2B5EF4-FFF2-40B4-BE49-F238E27FC236}">
+                <a16:creationId xmlns:a16="http://schemas.microsoft.com/office/drawing/2014/main" id="{B6B0AE37-9E65-42D0-C877-292F2FA1CBCE}"/>
+              </a:ext>
+            </a:extLst>
+          </p:cNvPr>
+          <p:cNvSpPr txBox="1"/>
+          <p:nvPr/>
+        </p:nvSpPr>
+        <p:spPr>
+          <a:xfrm>
+            <a:off x="4201636" y="3428999"/>
+            <a:ext cx="2169414" cy="646331"/>
+          </a:xfrm>
+          <a:prstGeom prst="rect">
+            <a:avLst/>
+          </a:prstGeom>
+          <a:noFill/>
+          <a:ln>
+            <a:noFill/>
+          </a:ln>
+        </p:spPr>
+        <p:style>
+          <a:lnRef idx="0">
+            <a:scrgbClr r="0" g="0" b="0"/>
+          </a:lnRef>
+          <a:fillRef idx="0">
+            <a:scrgbClr r="0" g="0" b="0"/>
+          </a:fillRef>
+          <a:effectRef idx="0">
+            <a:scrgbClr r="0" g="0" b="0"/>
+          </a:effectRef>
+          <a:fontRef idx="minor">
+            <a:schemeClr val="dk1"/>
+          </a:fontRef>
+        </p:style>
+        <p:txBody>
+          <a:bodyPr wrap="square" rtlCol="0">
+            <a:spAutoFit/>
+          </a:bodyPr>
+          <a:lstStyle/>
+          <a:p>
+            <a:pPr algn="ctr"/>
+            <a:r>
+              <a:rPr lang="en-US" dirty="0"/>
+              <a:t>Hybrid</a:t>
+            </a:r>
+          </a:p>
+          <a:p>
+            <a:pPr algn="ctr"/>
+            <a:r>
+              <a:rPr lang="en-US" dirty="0"/>
+              <a:t> Intelligence</a:t>
+            </a:r>
+          </a:p>
+        </p:txBody>
+      </p:sp>
+    </p:spTree>
+    <p:extLst>
+      <p:ext uri="{BB962C8B-B14F-4D97-AF65-F5344CB8AC3E}">
+        <p14:creationId xmlns:p14="http://schemas.microsoft.com/office/powerpoint/2010/main" val="3404937500"/>
+      </p:ext>
+    </p:extLst>
+  </p:cSld>
+  <p:clrMapOvr>
+    <a:masterClrMapping/>
+  </p:clrMapOvr>
+</p:sld>
+</file>
+
 <file path=ppt/theme/theme1.xml><?xml version="1.0" encoding="utf-8"?>
 <a:theme xmlns:a="http://schemas.openxmlformats.org/drawingml/2006/main" name="Kantoorthema">
   <a:themeElements>

</xml_diff>